<commit_message>
Update Presentation and Dart-Flutter practice files
</commit_message>
<xml_diff>
--- a/Documentation/Presentation.pptx
+++ b/Documentation/Presentation.pptx
@@ -3384,7 +3384,7 @@
         </p:nvSpPr>
         <p:spPr>
           <a:xfrm rot="0">
-            <a:off x="4833208" y="5648325"/>
+            <a:off x="4833208" y="5566200"/>
             <a:ext cx="8621583" cy="727320"/>
           </a:xfrm>
           <a:prstGeom prst="rect">
@@ -3415,20 +3415,64 @@
                 <a:cs typeface="Exo 2 Bold"/>
                 <a:sym typeface="Exo 2 Bold"/>
               </a:rPr>
-              <a:t>Медведєв Андрій Іванович ТВ-21</a:t>
-            </a:r>
-          </a:p>
-        </p:txBody>
-      </p:sp>
-      <p:sp>
-        <p:nvSpPr>
-          <p:cNvPr name="AutoShape 9" id="9"/>
+              <a:t>Медведєв Андрій Іванович</a:t>
+            </a:r>
+          </a:p>
+        </p:txBody>
+      </p:sp>
+      <p:sp>
+        <p:nvSpPr>
+          <p:cNvPr name="TextBox 9" id="9"/>
+          <p:cNvSpPr txBox="true"/>
+          <p:nvPr/>
+        </p:nvSpPr>
+        <p:spPr>
+          <a:xfrm rot="0">
+            <a:off x="3024007" y="7234445"/>
+            <a:ext cx="12239986" cy="727320"/>
+          </a:xfrm>
+          <a:prstGeom prst="rect">
+            <a:avLst/>
+          </a:prstGeom>
+        </p:spPr>
+        <p:txBody>
+          <a:bodyPr anchor="t" rtlCol="false" tIns="0" lIns="0" bIns="0" rIns="0">
+            <a:spAutoFit/>
+          </a:bodyPr>
+          <a:lstStyle/>
+          <a:p>
+            <a:pPr algn="ctr">
+              <a:lnSpc>
+                <a:spcPts val="5880"/>
+              </a:lnSpc>
+              <a:spcBef>
+                <a:spcPct val="0"/>
+              </a:spcBef>
+            </a:pPr>
+            <a:r>
+              <a:rPr lang="en-US" b="true" sz="4200">
+                <a:solidFill>
+                  <a:srgbClr val="1B3A6E"/>
+                </a:solidFill>
+                <a:latin typeface="Exo 2 Bold"/>
+                <a:ea typeface="Exo 2 Bold"/>
+                <a:cs typeface="Exo 2 Bold"/>
+                <a:sym typeface="Exo 2 Bold"/>
+              </a:rPr>
+              <a:t>Недашківський Олексій Леонідовин</a:t>
+            </a:r>
+          </a:p>
+        </p:txBody>
+      </p:sp>
+      <p:sp>
+        <p:nvSpPr>
+          <p:cNvPr name="AutoShape 10" id="10"/>
           <p:cNvSpPr/>
           <p:nvPr/>
         </p:nvSpPr>
         <p:spPr>
           <a:xfrm>
-            <a:off x="4152657" y="5317587"/>
+            <a:off x="4152657" y="5181600"/>
             <a:ext cx="9982687" cy="0"/>
           </a:xfrm>
           <a:prstGeom prst="line">
@@ -3697,8 +3741,8 @@
         </p:nvSpPr>
         <p:spPr>
           <a:xfrm rot="0">
-            <a:off x="1028700" y="2318487"/>
-            <a:ext cx="16230600" cy="1967098"/>
+            <a:off x="1028700" y="2365907"/>
+            <a:ext cx="16230600" cy="2462365"/>
           </a:xfrm>
           <a:prstGeom prst="rect">
             <a:avLst/>
@@ -3728,7 +3772,7 @@
                 <a:cs typeface="Exo 2"/>
                 <a:sym typeface="Exo 2"/>
               </a:rPr>
-              <a:t>Мова програмування Dart набуває все більшої популярності серед ІТ-</a:t>
+              <a:t>Мова програмування Dart та фреймворк Flutter останнім часом стрімко набувають популярності. Вони</a:t>
             </a:r>
             <a:r>
               <a:rPr lang="en-US" sz="2799">
@@ -3740,7 +3784,7 @@
                 <a:cs typeface="Exo 2"/>
                 <a:sym typeface="Exo 2"/>
               </a:rPr>
-              <a:t>компаній та розробників завдяки фреймворку Flutter, який дає змогу створювати кросплатформні мобільні застосунки з високою продуктивністю. Разом із цим зростає кількість навчальних матеріалів і документації для вивчення Dart.</a:t>
+              <a:t> дозволяють створювати кросплатформні мобільні застосунки з єдиною кодовою базою, що робить їх привабливим рішенням як для малих стартапів так і для великих проєктів. В результаті попит на фахівців зростає, однак якісних україномовних навчальних ресурсів з Dart практично не має, що суттєво ускладнює навчання для студентів.</a:t>
             </a:r>
           </a:p>
         </p:txBody>
@@ -3753,8 +3797,8 @@
         </p:nvSpPr>
         <p:spPr>
           <a:xfrm rot="0">
-            <a:off x="1028700" y="4569655"/>
-            <a:ext cx="16230600" cy="2462365"/>
+            <a:off x="1028700" y="5379561"/>
+            <a:ext cx="16230600" cy="1967098"/>
           </a:xfrm>
           <a:prstGeom prst="rect">
             <a:avLst/>
@@ -3784,7 +3828,7 @@
                 <a:cs typeface="Exo 2"/>
                 <a:sym typeface="Exo 2"/>
               </a:rPr>
-              <a:t>Однак значна частина таких ресурсів доступна лише англійською мовою, що ускладнює процес навч</a:t>
+              <a:t>Саме тому розробка україномовного навч</a:t>
             </a:r>
             <a:r>
               <a:rPr lang="en-US" sz="2799">
@@ -3796,7 +3840,7 @@
                 <a:cs typeface="Exo 2"/>
                 <a:sym typeface="Exo 2"/>
               </a:rPr>
-              <a:t>ання для україномовних користувачів. Тому важливо дослідити наявні українські джерела, порівняти їх з оригінальними англомовними, визначити їхні переваги й недоліки та оцінити, наскільки вони відповідають сучасним потребам розробників. Отримані результати надалі будуть використані для створення плану навчання та розроблення додатка.</a:t>
+              <a:t>ально-методичного комплексу є актуальним рішенням. Комплекс стане частиною системи є-Кафедра і об'єднає навчальні матеріали, практичні завдання та інструменти оцінювання в єдину платформу, корисну як для студентів що опановують мову так і для викладачів що організовують навчальний процес.</a:t>
             </a:r>
           </a:p>
         </p:txBody>
@@ -3950,124 +3994,8 @@
         </p:nvSpPr>
         <p:spPr>
           <a:xfrm rot="0">
-            <a:off x="1506957" y="9546440"/>
-            <a:ext cx="6290560" cy="486833"/>
-          </a:xfrm>
-          <a:prstGeom prst="rect">
-            <a:avLst/>
-          </a:prstGeom>
-        </p:spPr>
-        <p:txBody>
-          <a:bodyPr anchor="t" rtlCol="false" tIns="0" lIns="0" bIns="0" rIns="0">
-            <a:spAutoFit/>
-          </a:bodyPr>
-          <a:lstStyle/>
-          <a:p>
-            <a:pPr algn="l">
-              <a:lnSpc>
-                <a:spcPts val="1920"/>
-              </a:lnSpc>
-            </a:pPr>
-            <a:r>
-              <a:rPr lang="en-US" sz="1600" b="true">
-                <a:solidFill>
-                  <a:srgbClr val="FFFFFF"/>
-                </a:solidFill>
-                <a:latin typeface="Exo 2 Bold"/>
-                <a:ea typeface="Exo 2 Bold"/>
-                <a:cs typeface="Exo 2 Bold"/>
-                <a:sym typeface="Exo 2 Bold"/>
-              </a:rPr>
-              <a:t>Національний технічний університет України</a:t>
-            </a:r>
-          </a:p>
-          <a:p>
-            <a:pPr algn="l">
-              <a:lnSpc>
-                <a:spcPts val="1920"/>
-              </a:lnSpc>
-            </a:pPr>
-            <a:r>
-              <a:rPr lang="en-US" sz="1600" b="true">
-                <a:solidFill>
-                  <a:srgbClr val="FFFFFF"/>
-                </a:solidFill>
-                <a:latin typeface="Exo 2 Bold"/>
-                <a:ea typeface="Exo 2 Bold"/>
-                <a:cs typeface="Exo 2 Bold"/>
-                <a:sym typeface="Exo 2 Bold"/>
-              </a:rPr>
-              <a:t>«Київський політехнічний інститут імені Ігоря Сікорського»</a:t>
-            </a:r>
-          </a:p>
-        </p:txBody>
-      </p:sp>
-      <p:sp>
-        <p:nvSpPr>
-          <p:cNvPr name="TextBox 7" id="7"/>
-          <p:cNvSpPr txBox="true"/>
-          <p:nvPr/>
-        </p:nvSpPr>
-        <p:spPr>
-          <a:xfrm rot="0">
-            <a:off x="4833208" y="923925"/>
-            <a:ext cx="8621583" cy="890694"/>
-          </a:xfrm>
-          <a:prstGeom prst="rect">
-            <a:avLst/>
-          </a:prstGeom>
-        </p:spPr>
-        <p:txBody>
-          <a:bodyPr anchor="t" rtlCol="false" tIns="0" lIns="0" bIns="0" rIns="0">
-            <a:spAutoFit/>
-          </a:bodyPr>
-          <a:lstStyle/>
-          <a:p>
-            <a:pPr algn="ctr">
-              <a:lnSpc>
-                <a:spcPts val="7139"/>
-              </a:lnSpc>
-              <a:spcBef>
-                <a:spcPct val="0"/>
-              </a:spcBef>
-            </a:pPr>
-            <a:r>
-              <a:rPr lang="en-US" b="true" sz="5099">
-                <a:solidFill>
-                  <a:srgbClr val="1B3A6E"/>
-                </a:solidFill>
-                <a:latin typeface="Exo 2 Bold"/>
-                <a:ea typeface="Exo 2 Bold"/>
-                <a:cs typeface="Exo 2 Bold"/>
-                <a:sym typeface="Exo 2 Bold"/>
-              </a:rPr>
-              <a:t>МЕ</a:t>
-            </a:r>
-            <a:r>
-              <a:rPr lang="en-US" b="true" sz="5099">
-                <a:solidFill>
-                  <a:srgbClr val="1B3A6E"/>
-                </a:solidFill>
-                <a:latin typeface="Exo 2 Bold"/>
-                <a:ea typeface="Exo 2 Bold"/>
-                <a:cs typeface="Exo 2 Bold"/>
-                <a:sym typeface="Exo 2 Bold"/>
-              </a:rPr>
-              <a:t>ТА</a:t>
-            </a:r>
-          </a:p>
-        </p:txBody>
-      </p:sp>
-      <p:sp>
-        <p:nvSpPr>
-          <p:cNvPr name="TextBox 8" id="8"/>
-          <p:cNvSpPr txBox="true"/>
-          <p:nvPr/>
-        </p:nvSpPr>
-        <p:spPr>
-          <a:xfrm rot="0">
-            <a:off x="1028700" y="2318487"/>
-            <a:ext cx="16230600" cy="2462365"/>
+            <a:off x="1028700" y="2364746"/>
+            <a:ext cx="16230600" cy="1967098"/>
           </a:xfrm>
           <a:prstGeom prst="rect">
             <a:avLst/>
@@ -4097,7 +4025,7 @@
                 <a:cs typeface="Exo 2"/>
                 <a:sym typeface="Exo 2"/>
               </a:rPr>
-              <a:t>Метою даної роботи є дослідження, порівняння та аналіз актуальних джерел </a:t>
+              <a:t>Метою даної роботи є розробка навчально-методичного комплексу з</a:t>
             </a:r>
             <a:r>
               <a:rPr lang="en-US" sz="2799">
@@ -4109,21 +4037,21 @@
                 <a:cs typeface="Exo 2"/>
                 <a:sym typeface="Exo 2"/>
               </a:rPr>
-              <a:t>і навчальних матеріалів для вивчення мови програмування Dart. На основі отриманих результатів планується сформувати висновки, які визначатимуть напрям подальшого розвитку навчально-методичного комплексу з дисципліни «Кросплатформна розробка мобільних застосунків» на Dart.</a:t>
-            </a:r>
-          </a:p>
-        </p:txBody>
-      </p:sp>
-      <p:sp>
-        <p:nvSpPr>
-          <p:cNvPr name="Freeform 9" id="9"/>
+              <a:t> дисципліни «Кросплатформна розробка мобільних застосунків» на Dart, який надасть доступ до сучасного україномовного курсу для студентів та забезпечить викладачів зручними засобами організації навчального процесу у межах системи є-Кафедра.</a:t>
+            </a:r>
+          </a:p>
+        </p:txBody>
+      </p:sp>
+      <p:sp>
+        <p:nvSpPr>
+          <p:cNvPr name="Freeform 7" id="7"/>
           <p:cNvSpPr/>
           <p:nvPr/>
         </p:nvSpPr>
         <p:spPr>
           <a:xfrm flipH="false" flipV="false" rot="0">
-            <a:off x="5835949" y="4675084"/>
-            <a:ext cx="6616102" cy="3713287"/>
+            <a:off x="2311171" y="5143500"/>
+            <a:ext cx="5044075" cy="2830987"/>
           </a:xfrm>
           <a:custGeom>
             <a:avLst/>
@@ -4132,18 +4060,18 @@
             <a:cxnLst/>
             <a:rect r="r" b="b" t="t" l="l"/>
             <a:pathLst>
-              <a:path h="3713287" w="6616102">
+              <a:path h="2830987" w="5044075">
                 <a:moveTo>
                   <a:pt x="0" y="0"/>
                 </a:moveTo>
                 <a:lnTo>
-                  <a:pt x="6616102" y="0"/>
+                  <a:pt x="5044075" y="0"/>
                 </a:lnTo>
                 <a:lnTo>
-                  <a:pt x="6616102" y="3713287"/>
+                  <a:pt x="5044075" y="2830987"/>
                 </a:lnTo>
                 <a:lnTo>
-                  <a:pt x="0" y="3713287"/>
+                  <a:pt x="0" y="2830987"/>
                 </a:lnTo>
                 <a:lnTo>
                   <a:pt x="0" y="0"/>
@@ -4159,6 +4087,168 @@
             </a:stretch>
           </a:blipFill>
         </p:spPr>
+      </p:sp>
+      <p:sp>
+        <p:nvSpPr>
+          <p:cNvPr name="Freeform 8" id="8"/>
+          <p:cNvSpPr/>
+          <p:nvPr/>
+        </p:nvSpPr>
+        <p:spPr>
+          <a:xfrm flipH="false" flipV="false" rot="0">
+            <a:off x="10377638" y="5682005"/>
+            <a:ext cx="6154307" cy="1753977"/>
+          </a:xfrm>
+          <a:custGeom>
+            <a:avLst/>
+            <a:gdLst/>
+            <a:ahLst/>
+            <a:cxnLst/>
+            <a:rect r="r" b="b" t="t" l="l"/>
+            <a:pathLst>
+              <a:path h="1753977" w="6154307">
+                <a:moveTo>
+                  <a:pt x="0" y="0"/>
+                </a:moveTo>
+                <a:lnTo>
+                  <a:pt x="6154307" y="0"/>
+                </a:lnTo>
+                <a:lnTo>
+                  <a:pt x="6154307" y="1753977"/>
+                </a:lnTo>
+                <a:lnTo>
+                  <a:pt x="0" y="1753977"/>
+                </a:lnTo>
+                <a:lnTo>
+                  <a:pt x="0" y="0"/>
+                </a:lnTo>
+                <a:close/>
+              </a:path>
+            </a:pathLst>
+          </a:custGeom>
+          <a:blipFill>
+            <a:blip r:embed="rId4"/>
+            <a:stretch>
+              <a:fillRect l="0" t="0" r="0" b="0"/>
+            </a:stretch>
+          </a:blipFill>
+        </p:spPr>
+      </p:sp>
+      <p:sp>
+        <p:nvSpPr>
+          <p:cNvPr name="TextBox 9" id="9"/>
+          <p:cNvSpPr txBox="true"/>
+          <p:nvPr/>
+        </p:nvSpPr>
+        <p:spPr>
+          <a:xfrm rot="0">
+            <a:off x="1506957" y="9546440"/>
+            <a:ext cx="6290560" cy="486833"/>
+          </a:xfrm>
+          <a:prstGeom prst="rect">
+            <a:avLst/>
+          </a:prstGeom>
+        </p:spPr>
+        <p:txBody>
+          <a:bodyPr anchor="t" rtlCol="false" tIns="0" lIns="0" bIns="0" rIns="0">
+            <a:spAutoFit/>
+          </a:bodyPr>
+          <a:lstStyle/>
+          <a:p>
+            <a:pPr algn="l">
+              <a:lnSpc>
+                <a:spcPts val="1920"/>
+              </a:lnSpc>
+            </a:pPr>
+            <a:r>
+              <a:rPr lang="en-US" sz="1600" b="true">
+                <a:solidFill>
+                  <a:srgbClr val="FFFFFF"/>
+                </a:solidFill>
+                <a:latin typeface="Exo 2 Bold"/>
+                <a:ea typeface="Exo 2 Bold"/>
+                <a:cs typeface="Exo 2 Bold"/>
+                <a:sym typeface="Exo 2 Bold"/>
+              </a:rPr>
+              <a:t>Національний технічний університет України</a:t>
+            </a:r>
+          </a:p>
+          <a:p>
+            <a:pPr algn="l">
+              <a:lnSpc>
+                <a:spcPts val="1920"/>
+              </a:lnSpc>
+            </a:pPr>
+            <a:r>
+              <a:rPr lang="en-US" sz="1600" b="true">
+                <a:solidFill>
+                  <a:srgbClr val="FFFFFF"/>
+                </a:solidFill>
+                <a:latin typeface="Exo 2 Bold"/>
+                <a:ea typeface="Exo 2 Bold"/>
+                <a:cs typeface="Exo 2 Bold"/>
+                <a:sym typeface="Exo 2 Bold"/>
+              </a:rPr>
+              <a:t>«Київський політехнічний інститут імені Ігоря Сікорського»</a:t>
+            </a:r>
+          </a:p>
+        </p:txBody>
+      </p:sp>
+      <p:sp>
+        <p:nvSpPr>
+          <p:cNvPr name="TextBox 10" id="10"/>
+          <p:cNvSpPr txBox="true"/>
+          <p:nvPr/>
+        </p:nvSpPr>
+        <p:spPr>
+          <a:xfrm rot="0">
+            <a:off x="4833208" y="923925"/>
+            <a:ext cx="8621583" cy="890694"/>
+          </a:xfrm>
+          <a:prstGeom prst="rect">
+            <a:avLst/>
+          </a:prstGeom>
+        </p:spPr>
+        <p:txBody>
+          <a:bodyPr anchor="t" rtlCol="false" tIns="0" lIns="0" bIns="0" rIns="0">
+            <a:spAutoFit/>
+          </a:bodyPr>
+          <a:lstStyle/>
+          <a:p>
+            <a:pPr algn="ctr">
+              <a:lnSpc>
+                <a:spcPts val="7139"/>
+              </a:lnSpc>
+              <a:spcBef>
+                <a:spcPct val="0"/>
+              </a:spcBef>
+            </a:pPr>
+            <a:r>
+              <a:rPr lang="en-US" b="true" sz="5099">
+                <a:solidFill>
+                  <a:srgbClr val="1B3A6E"/>
+                </a:solidFill>
+                <a:latin typeface="Exo 2 Bold"/>
+                <a:ea typeface="Exo 2 Bold"/>
+                <a:cs typeface="Exo 2 Bold"/>
+                <a:sym typeface="Exo 2 Bold"/>
+              </a:rPr>
+              <a:t>МЕ</a:t>
+            </a:r>
+            <a:r>
+              <a:rPr lang="en-US" b="true" sz="5099">
+                <a:solidFill>
+                  <a:srgbClr val="1B3A6E"/>
+                </a:solidFill>
+                <a:latin typeface="Exo 2 Bold"/>
+                <a:ea typeface="Exo 2 Bold"/>
+                <a:cs typeface="Exo 2 Bold"/>
+                <a:sym typeface="Exo 2 Bold"/>
+              </a:rPr>
+              <a:t>ТА</a:t>
+            </a:r>
+          </a:p>
+        </p:txBody>
       </p:sp>
     </p:spTree>
   </p:cSld>
@@ -4537,7 +4627,7 @@
         </p:nvSpPr>
         <p:spPr>
           <a:xfrm rot="0">
-            <a:off x="1028700" y="5643037"/>
+            <a:off x="1028700" y="5643993"/>
             <a:ext cx="16230600" cy="1471831"/>
           </a:xfrm>
           <a:prstGeom prst="rect">
@@ -4568,7 +4658,7 @@
                 <a:cs typeface="Exo 2"/>
                 <a:sym typeface="Exo 2"/>
               </a:rPr>
-              <a:t>Методи, підходи та програмні засоби аналізу, створення й </a:t>
+              <a:t>Методи, підходи та програмні засоби створення, структурування і </a:t>
             </a:r>
             <a:r>
               <a:rPr lang="en-US" sz="2799">
@@ -4580,7 +4670,7 @@
                 <a:cs typeface="Exo 2"/>
                 <a:sym typeface="Exo 2"/>
               </a:rPr>
-              <a:t>використання навчально-методичних матеріалів і ресурсів для вивчення мови програмування Dart у процесі підготовки фахівців з інженерії програмного забезпечення.</a:t>
+              <a:t>використання навчально-методичних матеріалів для вивчення мови програмування Dart та забезпечення якісної організації навчального процесу і оцінювання результатів навчання студентів.</a:t>
             </a:r>
           </a:p>
         </p:txBody>

</xml_diff>